<commit_message>
fix(pitch): adjust vertical layout geometry and paragraph spacing to eliminate text collisions in PPTX and PDF
</commit_message>
<xml_diff>
--- a/output/presentation/hapus-scout-day1.pptx
+++ b/output/presentation/hapus-scout-day1.pptx
@@ -3105,7 +3105,7 @@
         <p:spPr>
           <a:xfrm>
             <a:off x="571500" y="285750"/>
-            <a:ext cx="11049000" cy="428625"/>
+            <a:ext cx="11049000" cy="333375"/>
           </a:xfrm>
           <a:prstGeom prst="rect">
             <a:avLst/>
@@ -3119,7 +3119,10 @@
           <a:lstStyle/>
           <a:p>
             <a:pPr>
-              <a:defRPr sz="3200" b="1">
+              <a:spcAft>
+                <a:spcPts val="200"/>
+              </a:spcAft>
+              <a:defRPr sz="2600" b="1">
                 <a:solidFill>
                   <a:srgbClr val="173F2E"/>
                 </a:solidFill>
@@ -3140,8 +3143,8 @@
         </p:nvSpPr>
         <p:spPr>
           <a:xfrm>
-            <a:off x="571500" y="742950"/>
-            <a:ext cx="11049000" cy="266700"/>
+            <a:off x="571500" y="647700"/>
+            <a:ext cx="11049000" cy="209550"/>
           </a:xfrm>
           <a:prstGeom prst="rect">
             <a:avLst/>
@@ -3155,7 +3158,10 @@
           <a:lstStyle/>
           <a:p>
             <a:pPr>
-              <a:defRPr sz="1600" b="0">
+              <a:spcAft>
+                <a:spcPts val="200"/>
+              </a:spcAft>
+              <a:defRPr sz="1300" b="0">
                 <a:solidFill>
                   <a:srgbClr val="435749"/>
                 </a:solidFill>
@@ -3176,8 +3182,8 @@
         </p:nvSpPr>
         <p:spPr>
           <a:xfrm>
-            <a:off x="571500" y="1143000"/>
-            <a:ext cx="5334000" cy="238125"/>
+            <a:off x="571500" y="1000125"/>
+            <a:ext cx="5238750" cy="190500"/>
           </a:xfrm>
           <a:prstGeom prst="rect">
             <a:avLst/>
@@ -3191,7 +3197,10 @@
           <a:lstStyle/>
           <a:p>
             <a:pPr>
-              <a:defRPr sz="1600" b="1">
+              <a:spcAft>
+                <a:spcPts val="200"/>
+              </a:spcAft>
+              <a:defRPr sz="1400" b="1">
                 <a:solidFill>
                   <a:srgbClr val="173F2E"/>
                 </a:solidFill>
@@ -3212,8 +3221,8 @@
         </p:nvSpPr>
         <p:spPr>
           <a:xfrm>
-            <a:off x="571500" y="1409700"/>
-            <a:ext cx="5334000" cy="1143000"/>
+            <a:off x="571500" y="1219200"/>
+            <a:ext cx="5238750" cy="1047749"/>
           </a:xfrm>
           <a:prstGeom prst="rect">
             <a:avLst/>
@@ -3227,7 +3236,10 @@
           <a:lstStyle/>
           <a:p>
             <a:pPr>
-              <a:defRPr sz="1200" b="0">
+              <a:spcAft>
+                <a:spcPts val="200"/>
+              </a:spcAft>
+              <a:defRPr sz="1050" b="0">
                 <a:solidFill>
                   <a:srgbClr val="273D30"/>
                 </a:solidFill>
@@ -3237,11 +3249,35 @@
             <a:r>
               <a:t>• Problem: Alphonso mangoes suffer 35-40% annual crop loss from unmonitored pest outbreaks.</a:t>
             </a:r>
-            <a:br/>
+          </a:p>
+          <a:p>
+            <a:pPr>
+              <a:spcAft>
+                <a:spcPts val="200"/>
+              </a:spcAft>
+              <a:defRPr sz="1050" b="0">
+                <a:solidFill>
+                  <a:srgbClr val="273D30"/>
+                </a:solidFill>
+                <a:latin typeface="Arial"/>
+              </a:defRPr>
+            </a:pPr>
             <a:r>
               <a:t>• Solution: Sub-6.5s vision AI triage converts worker photos into actionable agronomic briefs.</a:t>
             </a:r>
-            <a:br/>
+          </a:p>
+          <a:p>
+            <a:pPr>
+              <a:spcAft>
+                <a:spcPts val="200"/>
+              </a:spcAft>
+              <a:defRPr sz="1050" b="0">
+                <a:solidFill>
+                  <a:srgbClr val="273D30"/>
+                </a:solidFill>
+                <a:latin typeface="Arial"/>
+              </a:defRPr>
+            </a:pPr>
             <a:r>
               <a:t>• ROI &amp; Scale: Replaces ₹1,500/visit fees; enables 1 agronomist to oversee 500+ orchard blocks.</a:t>
             </a:r>
@@ -3256,8 +3292,8 @@
         </p:nvSpPr>
         <p:spPr>
           <a:xfrm>
-            <a:off x="6286500" y="1143000"/>
-            <a:ext cx="5334000" cy="238125"/>
+            <a:off x="6381750" y="1000125"/>
+            <a:ext cx="5238750" cy="190500"/>
           </a:xfrm>
           <a:prstGeom prst="rect">
             <a:avLst/>
@@ -3271,7 +3307,10 @@
           <a:lstStyle/>
           <a:p>
             <a:pPr>
-              <a:defRPr sz="1600" b="1">
+              <a:spcAft>
+                <a:spcPts val="200"/>
+              </a:spcAft>
+              <a:defRPr sz="1400" b="1">
                 <a:solidFill>
                   <a:srgbClr val="173F2E"/>
                 </a:solidFill>
@@ -3292,8 +3331,8 @@
         </p:nvSpPr>
         <p:spPr>
           <a:xfrm>
-            <a:off x="6286500" y="1409700"/>
-            <a:ext cx="5334000" cy="1143000"/>
+            <a:off x="6381750" y="1219200"/>
+            <a:ext cx="5238750" cy="1047749"/>
           </a:xfrm>
           <a:prstGeom prst="rect">
             <a:avLst/>
@@ -3307,7 +3346,10 @@
           <a:lstStyle/>
           <a:p>
             <a:pPr>
-              <a:defRPr sz="1200" b="0">
+              <a:spcAft>
+                <a:spcPts val="200"/>
+              </a:spcAft>
+              <a:defRPr sz="1050" b="0">
                 <a:solidFill>
                   <a:srgbClr val="273D30"/>
                 </a:solidFill>
@@ -3317,11 +3359,35 @@
             <a:r>
               <a:t>• Problem: Over 85% of Konkan orchard workers are native Marathi or Hindi speakers.</a:t>
             </a:r>
-            <a:br/>
-            <a:r>
-              <a:t>• Solution: Multilingual UI (EN, MR, HI) dynamically aligns local dialect terms (Karpa) to AI tensors.</a:t>
-            </a:r>
-            <a:br/>
+          </a:p>
+          <a:p>
+            <a:pPr>
+              <a:spcAft>
+                <a:spcPts val="200"/>
+              </a:spcAft>
+              <a:defRPr sz="1050" b="0">
+                <a:solidFill>
+                  <a:srgbClr val="273D30"/>
+                </a:solidFill>
+                <a:latin typeface="Arial"/>
+              </a:defRPr>
+            </a:pPr>
+            <a:r>
+              <a:t>• Solution: Multilingual UI (EN, MR, HI) dynamically aligns local terms (Karpa) to AI tensors.</a:t>
+            </a:r>
+          </a:p>
+          <a:p>
+            <a:pPr>
+              <a:spcAft>
+                <a:spcPts val="200"/>
+              </a:spcAft>
+              <a:defRPr sz="1050" b="0">
+                <a:solidFill>
+                  <a:srgbClr val="273D30"/>
+                </a:solidFill>
+                <a:latin typeface="Arial"/>
+              </a:defRPr>
+            </a:pPr>
             <a:r>
               <a:t>• ROI &amp; Scale: Zero worker training costs; seamless adoption across regional labor pools.</a:t>
             </a:r>
@@ -3336,8 +3402,8 @@
         </p:nvSpPr>
         <p:spPr>
           <a:xfrm>
-            <a:off x="571500" y="2667000"/>
-            <a:ext cx="5334000" cy="238125"/>
+            <a:off x="571500" y="2428875"/>
+            <a:ext cx="5238750" cy="190500"/>
           </a:xfrm>
           <a:prstGeom prst="rect">
             <a:avLst/>
@@ -3351,7 +3417,10 @@
           <a:lstStyle/>
           <a:p>
             <a:pPr>
-              <a:defRPr sz="1600" b="1">
+              <a:spcAft>
+                <a:spcPts val="200"/>
+              </a:spcAft>
+              <a:defRPr sz="1400" b="1">
                 <a:solidFill>
                   <a:srgbClr val="173F2E"/>
                 </a:solidFill>
@@ -3372,8 +3441,8 @@
         </p:nvSpPr>
         <p:spPr>
           <a:xfrm>
-            <a:off x="571500" y="2933700"/>
-            <a:ext cx="5334000" cy="1143000"/>
+            <a:off x="571500" y="2647950"/>
+            <a:ext cx="5238750" cy="1047749"/>
           </a:xfrm>
           <a:prstGeom prst="rect">
             <a:avLst/>
@@ -3387,7 +3456,10 @@
           <a:lstStyle/>
           <a:p>
             <a:pPr>
-              <a:defRPr sz="1200" b="0">
+              <a:spcAft>
+                <a:spcPts val="200"/>
+              </a:spcAft>
+              <a:defRPr sz="1050" b="0">
                 <a:solidFill>
                   <a:srgbClr val="273D30"/>
                 </a:solidFill>
@@ -3397,11 +3469,35 @@
             <a:r>
               <a:t>• Problem: Farmers spend ₹15k-40k/acre on panic chemical spraying, causing export rejections.</a:t>
             </a:r>
-            <a:br/>
+          </a:p>
+          <a:p>
+            <a:pPr>
+              <a:spcAft>
+                <a:spcPts val="200"/>
+              </a:spcAft>
+              <a:defRPr sz="1050" b="0">
+                <a:solidFill>
+                  <a:srgbClr val="273D30"/>
+                </a:solidFill>
+                <a:latin typeface="Arial"/>
+              </a:defRPr>
+            </a:pPr>
             <a:r>
               <a:t>• Solution: Grounded ICAR rules isolate physical observations from unconfirmed hypotheses.</a:t>
             </a:r>
-            <a:br/>
+          </a:p>
+          <a:p>
+            <a:pPr>
+              <a:spcAft>
+                <a:spcPts val="200"/>
+              </a:spcAft>
+              <a:defRPr sz="1050" b="0">
+                <a:solidFill>
+                  <a:srgbClr val="273D30"/>
+                </a:solidFill>
+                <a:latin typeface="Arial"/>
+              </a:defRPr>
+            </a:pPr>
             <a:r>
               <a:t>• ROI &amp; Scale: Cuts pesticide spending by 40-60%; protects EU/US premium export compliance.</a:t>
             </a:r>
@@ -3416,8 +3512,8 @@
         </p:nvSpPr>
         <p:spPr>
           <a:xfrm>
-            <a:off x="6286500" y="2667000"/>
-            <a:ext cx="5334000" cy="238125"/>
+            <a:off x="6381750" y="2428875"/>
+            <a:ext cx="5238750" cy="190500"/>
           </a:xfrm>
           <a:prstGeom prst="rect">
             <a:avLst/>
@@ -3431,7 +3527,10 @@
           <a:lstStyle/>
           <a:p>
             <a:pPr>
-              <a:defRPr sz="1600" b="1">
+              <a:spcAft>
+                <a:spcPts val="200"/>
+              </a:spcAft>
+              <a:defRPr sz="1400" b="1">
                 <a:solidFill>
                   <a:srgbClr val="173F2E"/>
                 </a:solidFill>
@@ -3452,8 +3551,8 @@
         </p:nvSpPr>
         <p:spPr>
           <a:xfrm>
-            <a:off x="6286500" y="2933700"/>
-            <a:ext cx="5334000" cy="1143000"/>
+            <a:off x="6381750" y="2647950"/>
+            <a:ext cx="5238750" cy="1047749"/>
           </a:xfrm>
           <a:prstGeom prst="rect">
             <a:avLst/>
@@ -3467,7 +3566,10 @@
           <a:lstStyle/>
           <a:p>
             <a:pPr>
-              <a:defRPr sz="1200" b="0">
+              <a:spcAft>
+                <a:spcPts val="200"/>
+              </a:spcAft>
+              <a:defRPr sz="1050" b="0">
                 <a:solidFill>
                   <a:srgbClr val="273D30"/>
                 </a:solidFill>
@@ -3477,11 +3579,35 @@
             <a:r>
               <a:t>• Problem: Informal WhatsApp/paper notes leave farm managers with zero auditable evidence logs.</a:t>
             </a:r>
-            <a:br/>
+          </a:p>
+          <a:p>
+            <a:pPr>
+              <a:spcAft>
+                <a:spcPts val="200"/>
+              </a:spcAft>
+              <a:defRPr sz="1050" b="0">
+                <a:solidFill>
+                  <a:srgbClr val="273D30"/>
+                </a:solidFill>
+                <a:latin typeface="Arial"/>
+              </a:defRPr>
+            </a:pPr>
             <a:r>
               <a:t>• Solution: Centralized CaseStore with timestamped audit trails &amp; 1-click agronomist reviews.</a:t>
             </a:r>
-            <a:br/>
+          </a:p>
+          <a:p>
+            <a:pPr>
+              <a:spcAft>
+                <a:spcPts val="200"/>
+              </a:spcAft>
+              <a:defRPr sz="1050" b="0">
+                <a:solidFill>
+                  <a:srgbClr val="273D30"/>
+                </a:solidFill>
+                <a:latin typeface="Arial"/>
+              </a:defRPr>
+            </a:pPr>
             <a:r>
               <a:t>• ROI &amp; Scale: Multi-tenant JSON database scales from 2-acre family farms to 1,000+ acre estates.</a:t>
             </a:r>
@@ -3496,8 +3622,8 @@
         </p:nvSpPr>
         <p:spPr>
           <a:xfrm>
-            <a:off x="571500" y="4238625"/>
-            <a:ext cx="11049000" cy="285750"/>
+            <a:off x="571500" y="3857625"/>
+            <a:ext cx="11049000" cy="190500"/>
           </a:xfrm>
           <a:prstGeom prst="rect">
             <a:avLst/>
@@ -3511,7 +3637,10 @@
           <a:lstStyle/>
           <a:p>
             <a:pPr>
-              <a:defRPr sz="1400" b="1">
+              <a:spcAft>
+                <a:spcPts val="200"/>
+              </a:spcAft>
+              <a:defRPr sz="1200" b="1">
                 <a:solidFill>
                   <a:srgbClr val="173F2E"/>
                 </a:solidFill>
@@ -3519,7 +3648,7 @@
               </a:defRPr>
             </a:pPr>
             <a:r>
-              <a:t>💰 COSTING: 92% TCO Reduction (Open 4-Bit Vision Engine)  |  ⚡ PERFORMANCE: &lt;6.5s Latency (1024 Patches)  |  📈 SCALABILITY: Regional Multilingual Scale</a:t>
+              <a:t>STRATEGIC EXECUTION &amp; ROI METRICS</a:t>
             </a:r>
           </a:p>
         </p:txBody>
@@ -3532,7 +3661,117 @@
         </p:nvSpPr>
         <p:spPr>
           <a:xfrm>
-            <a:off x="571500" y="4619625"/>
+            <a:off x="571500" y="4076699"/>
+            <a:ext cx="11049000" cy="571500"/>
+          </a:xfrm>
+          <a:prstGeom prst="rect">
+            <a:avLst/>
+          </a:prstGeom>
+          <a:noFill/>
+        </p:spPr>
+        <p:txBody>
+          <a:bodyPr wrap="square" lIns="0" tIns="0" rIns="0" bIns="0">
+            <a:spAutoFit/>
+          </a:bodyPr>
+          <a:lstStyle/>
+          <a:p>
+            <a:pPr>
+              <a:spcAft>
+                <a:spcPts val="200"/>
+              </a:spcAft>
+              <a:defRPr sz="1000" b="0">
+                <a:solidFill>
+                  <a:srgbClr val="273D30"/>
+                </a:solidFill>
+                <a:latin typeface="Arial"/>
+              </a:defRPr>
+            </a:pPr>
+            <a:r>
+              <a:t>• COSTING: 92% Total Cost of Ownership reduction using open 4-bit NF4 vision engine vs. commercial vision APIs.</a:t>
+            </a:r>
+          </a:p>
+          <a:p>
+            <a:pPr>
+              <a:spcAft>
+                <a:spcPts val="200"/>
+              </a:spcAft>
+              <a:defRPr sz="1000" b="0">
+                <a:solidFill>
+                  <a:srgbClr val="273D30"/>
+                </a:solidFill>
+                <a:latin typeface="Arial"/>
+              </a:defRPr>
+            </a:pPr>
+            <a:r>
+              <a:t>• PERFORMANCE: Sub-6.5s triage response time processing 1,024 vision patches at ~118ms/tok latency on T4 GPU.</a:t>
+            </a:r>
+          </a:p>
+          <a:p>
+            <a:pPr>
+              <a:spcAft>
+                <a:spcPts val="200"/>
+              </a:spcAft>
+              <a:defRPr sz="1000" b="0">
+                <a:solidFill>
+                  <a:srgbClr val="273D30"/>
+                </a:solidFill>
+                <a:latin typeface="Arial"/>
+              </a:defRPr>
+            </a:pPr>
+            <a:r>
+              <a:t>• SCALABILITY: Multi-tenant JSON storage architecture supporting regional multilingual scale across Konkan.</a:t>
+            </a:r>
+          </a:p>
+        </p:txBody>
+      </p:sp>
+      <p:sp>
+        <p:nvSpPr>
+          <p:cNvPr id="14" name="TextBox 13"/>
+          <p:cNvSpPr txBox="1"/>
+          <p:nvPr/>
+        </p:nvSpPr>
+        <p:spPr>
+          <a:xfrm>
+            <a:off x="571500" y="4810125"/>
+            <a:ext cx="11049000" cy="171450"/>
+          </a:xfrm>
+          <a:prstGeom prst="rect">
+            <a:avLst/>
+          </a:prstGeom>
+          <a:noFill/>
+        </p:spPr>
+        <p:txBody>
+          <a:bodyPr wrap="square" lIns="0" tIns="0" rIns="0" bIns="0">
+            <a:spAutoFit/>
+          </a:bodyPr>
+          <a:lstStyle/>
+          <a:p>
+            <a:pPr>
+              <a:spcAft>
+                <a:spcPts val="200"/>
+              </a:spcAft>
+              <a:defRPr sz="1000" b="1">
+                <a:solidFill>
+                  <a:srgbClr val="6D6345"/>
+                </a:solidFill>
+                <a:latin typeface="Arial"/>
+              </a:defRPr>
+            </a:pPr>
+            <a:r>
+              <a:t>AGRONOMIC GUARDRAIL &amp; REPOSITORY INFORMATION</a:t>
+            </a:r>
+          </a:p>
+        </p:txBody>
+      </p:sp>
+      <p:sp>
+        <p:nvSpPr>
+          <p:cNvPr id="15" name="TextBox 14"/>
+          <p:cNvSpPr txBox="1"/>
+          <p:nvPr/>
+        </p:nvSpPr>
+        <p:spPr>
+          <a:xfrm>
+            <a:off x="571500" y="5000625"/>
             <a:ext cx="11049000" cy="381000"/>
           </a:xfrm>
           <a:prstGeom prst="rect">
@@ -3547,7 +3786,10 @@
           <a:lstStyle/>
           <a:p>
             <a:pPr>
-              <a:defRPr sz="1000" b="0">
+              <a:spcAft>
+                <a:spcPts val="200"/>
+              </a:spcAft>
+              <a:defRPr sz="900" b="0">
                 <a:solidFill>
                   <a:srgbClr val="6D6345"/>
                 </a:solidFill>
@@ -3555,11 +3797,23 @@
               </a:defRPr>
             </a:pPr>
             <a:r>
-              <a:t>Agronomic Guardrail Notice: AI analysis supports triage evidence isolation. Certified agronomist verification mandatory before chemical application.</a:t>
-            </a:r>
-            <a:br/>
-            <a:r>
-              <a:t>Live Repository: https://github.com/HarshadHindlekar/Hapus-Scout.git  |  Vertical AI Track — Pitch Fest Edition</a:t>
+              <a:t>• Agronomic Guardrail Notice: AI analysis supports triage evidence isolation. Certified agronomist verification mandatory before chemical application.</a:t>
+            </a:r>
+          </a:p>
+          <a:p>
+            <a:pPr>
+              <a:spcAft>
+                <a:spcPts val="200"/>
+              </a:spcAft>
+              <a:defRPr sz="900" b="0">
+                <a:solidFill>
+                  <a:srgbClr val="6D6345"/>
+                </a:solidFill>
+                <a:latin typeface="Arial"/>
+              </a:defRPr>
+            </a:pPr>
+            <a:r>
+              <a:t>• Live Repository: https://github.com/HarshadHindlekar/Hapus-Scout.git  |  Vertical AI Track — Day-1 Builders Pitch Fest Edition</a:t>
             </a:r>
           </a:p>
         </p:txBody>

</xml_diff>

<commit_message>
fix(pitch): optimize vertical layout with generous 40px padding gaps to prevent footer collisions
</commit_message>
<xml_diff>
--- a/output/presentation/hapus-scout-day1.pptx
+++ b/output/presentation/hapus-scout-day1.pptx
@@ -3105,7 +3105,7 @@
         <p:spPr>
           <a:xfrm>
             <a:off x="571500" y="285750"/>
-            <a:ext cx="11049000" cy="333375"/>
+            <a:ext cx="11049000" cy="304800"/>
           </a:xfrm>
           <a:prstGeom prst="rect">
             <a:avLst/>
@@ -3122,7 +3122,7 @@
               <a:spcAft>
                 <a:spcPts val="200"/>
               </a:spcAft>
-              <a:defRPr sz="2600" b="1">
+              <a:defRPr sz="2400" b="1">
                 <a:solidFill>
                   <a:srgbClr val="173F2E"/>
                 </a:solidFill>
@@ -3143,486 +3143,7 @@
         </p:nvSpPr>
         <p:spPr>
           <a:xfrm>
-            <a:off x="571500" y="647700"/>
-            <a:ext cx="11049000" cy="209550"/>
-          </a:xfrm>
-          <a:prstGeom prst="rect">
-            <a:avLst/>
-          </a:prstGeom>
-          <a:noFill/>
-        </p:spPr>
-        <p:txBody>
-          <a:bodyPr wrap="square" lIns="0" tIns="0" rIns="0" bIns="0">
-            <a:spAutoFit/>
-          </a:bodyPr>
-          <a:lstStyle/>
-          <a:p>
-            <a:pPr>
-              <a:spcAft>
-                <a:spcPts val="200"/>
-              </a:spcAft>
-              <a:defRPr sz="1300" b="0">
-                <a:solidFill>
-                  <a:srgbClr val="435749"/>
-                </a:solidFill>
-                <a:latin typeface="Arial"/>
-              </a:defRPr>
-            </a:pPr>
-            <a:r>
-              <a:t>Multimodal Vision AI Orchard Inspection &amp; Agronomic Evidence Triage Platform for Alphonso Mangoes</a:t>
-            </a:r>
-          </a:p>
-        </p:txBody>
-      </p:sp>
-      <p:sp>
-        <p:nvSpPr>
-          <p:cNvPr id="4" name="TextBox 3"/>
-          <p:cNvSpPr txBox="1"/>
-          <p:nvPr/>
-        </p:nvSpPr>
-        <p:spPr>
-          <a:xfrm>
-            <a:off x="571500" y="1000125"/>
-            <a:ext cx="5238750" cy="190500"/>
-          </a:xfrm>
-          <a:prstGeom prst="rect">
-            <a:avLst/>
-          </a:prstGeom>
-          <a:noFill/>
-        </p:spPr>
-        <p:txBody>
-          <a:bodyPr wrap="square" lIns="0" tIns="0" rIns="0" bIns="0">
-            <a:spAutoFit/>
-          </a:bodyPr>
-          <a:lstStyle/>
-          <a:p>
-            <a:pPr>
-              <a:spcAft>
-                <a:spcPts val="200"/>
-              </a:spcAft>
-              <a:defRPr sz="1400" b="1">
-                <a:solidFill>
-                  <a:srgbClr val="173F2E"/>
-                </a:solidFill>
-                <a:latin typeface="Arial"/>
-              </a:defRPr>
-            </a:pPr>
-            <a:r>
-              <a:t>1. Delayed Disease Triage &amp; Crop Loss</a:t>
-            </a:r>
-          </a:p>
-        </p:txBody>
-      </p:sp>
-      <p:sp>
-        <p:nvSpPr>
-          <p:cNvPr id="5" name="TextBox 4"/>
-          <p:cNvSpPr txBox="1"/>
-          <p:nvPr/>
-        </p:nvSpPr>
-        <p:spPr>
-          <a:xfrm>
-            <a:off x="571500" y="1219200"/>
-            <a:ext cx="5238750" cy="1047749"/>
-          </a:xfrm>
-          <a:prstGeom prst="rect">
-            <a:avLst/>
-          </a:prstGeom>
-          <a:noFill/>
-        </p:spPr>
-        <p:txBody>
-          <a:bodyPr wrap="square" lIns="0" tIns="0" rIns="0" bIns="0">
-            <a:spAutoFit/>
-          </a:bodyPr>
-          <a:lstStyle/>
-          <a:p>
-            <a:pPr>
-              <a:spcAft>
-                <a:spcPts val="200"/>
-              </a:spcAft>
-              <a:defRPr sz="1050" b="0">
-                <a:solidFill>
-                  <a:srgbClr val="273D30"/>
-                </a:solidFill>
-                <a:latin typeface="Arial"/>
-              </a:defRPr>
-            </a:pPr>
-            <a:r>
-              <a:t>• Problem: Alphonso mangoes suffer 35-40% annual crop loss from unmonitored pest outbreaks.</a:t>
-            </a:r>
-          </a:p>
-          <a:p>
-            <a:pPr>
-              <a:spcAft>
-                <a:spcPts val="200"/>
-              </a:spcAft>
-              <a:defRPr sz="1050" b="0">
-                <a:solidFill>
-                  <a:srgbClr val="273D30"/>
-                </a:solidFill>
-                <a:latin typeface="Arial"/>
-              </a:defRPr>
-            </a:pPr>
-            <a:r>
-              <a:t>• Solution: Sub-6.5s vision AI triage converts worker photos into actionable agronomic briefs.</a:t>
-            </a:r>
-          </a:p>
-          <a:p>
-            <a:pPr>
-              <a:spcAft>
-                <a:spcPts val="200"/>
-              </a:spcAft>
-              <a:defRPr sz="1050" b="0">
-                <a:solidFill>
-                  <a:srgbClr val="273D30"/>
-                </a:solidFill>
-                <a:latin typeface="Arial"/>
-              </a:defRPr>
-            </a:pPr>
-            <a:r>
-              <a:t>• ROI &amp; Scale: Replaces ₹1,500/visit fees; enables 1 agronomist to oversee 500+ orchard blocks.</a:t>
-            </a:r>
-          </a:p>
-        </p:txBody>
-      </p:sp>
-      <p:sp>
-        <p:nvSpPr>
-          <p:cNvPr id="6" name="TextBox 5"/>
-          <p:cNvSpPr txBox="1"/>
-          <p:nvPr/>
-        </p:nvSpPr>
-        <p:spPr>
-          <a:xfrm>
-            <a:off x="6381750" y="1000125"/>
-            <a:ext cx="5238750" cy="190500"/>
-          </a:xfrm>
-          <a:prstGeom prst="rect">
-            <a:avLst/>
-          </a:prstGeom>
-          <a:noFill/>
-        </p:spPr>
-        <p:txBody>
-          <a:bodyPr wrap="square" lIns="0" tIns="0" rIns="0" bIns="0">
-            <a:spAutoFit/>
-          </a:bodyPr>
-          <a:lstStyle/>
-          <a:p>
-            <a:pPr>
-              <a:spcAft>
-                <a:spcPts val="200"/>
-              </a:spcAft>
-              <a:defRPr sz="1400" b="1">
-                <a:solidFill>
-                  <a:srgbClr val="173F2E"/>
-                </a:solidFill>
-                <a:latin typeface="Arial"/>
-              </a:defRPr>
-            </a:pPr>
-            <a:r>
-              <a:t>2. Field Worker Language Barrier</a:t>
-            </a:r>
-          </a:p>
-        </p:txBody>
-      </p:sp>
-      <p:sp>
-        <p:nvSpPr>
-          <p:cNvPr id="7" name="TextBox 6"/>
-          <p:cNvSpPr txBox="1"/>
-          <p:nvPr/>
-        </p:nvSpPr>
-        <p:spPr>
-          <a:xfrm>
-            <a:off x="6381750" y="1219200"/>
-            <a:ext cx="5238750" cy="1047749"/>
-          </a:xfrm>
-          <a:prstGeom prst="rect">
-            <a:avLst/>
-          </a:prstGeom>
-          <a:noFill/>
-        </p:spPr>
-        <p:txBody>
-          <a:bodyPr wrap="square" lIns="0" tIns="0" rIns="0" bIns="0">
-            <a:spAutoFit/>
-          </a:bodyPr>
-          <a:lstStyle/>
-          <a:p>
-            <a:pPr>
-              <a:spcAft>
-                <a:spcPts val="200"/>
-              </a:spcAft>
-              <a:defRPr sz="1050" b="0">
-                <a:solidFill>
-                  <a:srgbClr val="273D30"/>
-                </a:solidFill>
-                <a:latin typeface="Arial"/>
-              </a:defRPr>
-            </a:pPr>
-            <a:r>
-              <a:t>• Problem: Over 85% of Konkan orchard workers are native Marathi or Hindi speakers.</a:t>
-            </a:r>
-          </a:p>
-          <a:p>
-            <a:pPr>
-              <a:spcAft>
-                <a:spcPts val="200"/>
-              </a:spcAft>
-              <a:defRPr sz="1050" b="0">
-                <a:solidFill>
-                  <a:srgbClr val="273D30"/>
-                </a:solidFill>
-                <a:latin typeface="Arial"/>
-              </a:defRPr>
-            </a:pPr>
-            <a:r>
-              <a:t>• Solution: Multilingual UI (EN, MR, HI) dynamically aligns local terms (Karpa) to AI tensors.</a:t>
-            </a:r>
-          </a:p>
-          <a:p>
-            <a:pPr>
-              <a:spcAft>
-                <a:spcPts val="200"/>
-              </a:spcAft>
-              <a:defRPr sz="1050" b="0">
-                <a:solidFill>
-                  <a:srgbClr val="273D30"/>
-                </a:solidFill>
-                <a:latin typeface="Arial"/>
-              </a:defRPr>
-            </a:pPr>
-            <a:r>
-              <a:t>• ROI &amp; Scale: Zero worker training costs; seamless adoption across regional labor pools.</a:t>
-            </a:r>
-          </a:p>
-        </p:txBody>
-      </p:sp>
-      <p:sp>
-        <p:nvSpPr>
-          <p:cNvPr id="8" name="TextBox 7"/>
-          <p:cNvSpPr txBox="1"/>
-          <p:nvPr/>
-        </p:nvSpPr>
-        <p:spPr>
-          <a:xfrm>
-            <a:off x="571500" y="2428875"/>
-            <a:ext cx="5238750" cy="190500"/>
-          </a:xfrm>
-          <a:prstGeom prst="rect">
-            <a:avLst/>
-          </a:prstGeom>
-          <a:noFill/>
-        </p:spPr>
-        <p:txBody>
-          <a:bodyPr wrap="square" lIns="0" tIns="0" rIns="0" bIns="0">
-            <a:spAutoFit/>
-          </a:bodyPr>
-          <a:lstStyle/>
-          <a:p>
-            <a:pPr>
-              <a:spcAft>
-                <a:spcPts val="200"/>
-              </a:spcAft>
-              <a:defRPr sz="1400" b="1">
-                <a:solidFill>
-                  <a:srgbClr val="173F2E"/>
-                </a:solidFill>
-                <a:latin typeface="Arial"/>
-              </a:defRPr>
-            </a:pPr>
-            <a:r>
-              <a:t>3. Over-Spraying &amp; Export Rejections</a:t>
-            </a:r>
-          </a:p>
-        </p:txBody>
-      </p:sp>
-      <p:sp>
-        <p:nvSpPr>
-          <p:cNvPr id="9" name="TextBox 8"/>
-          <p:cNvSpPr txBox="1"/>
-          <p:nvPr/>
-        </p:nvSpPr>
-        <p:spPr>
-          <a:xfrm>
-            <a:off x="571500" y="2647950"/>
-            <a:ext cx="5238750" cy="1047749"/>
-          </a:xfrm>
-          <a:prstGeom prst="rect">
-            <a:avLst/>
-          </a:prstGeom>
-          <a:noFill/>
-        </p:spPr>
-        <p:txBody>
-          <a:bodyPr wrap="square" lIns="0" tIns="0" rIns="0" bIns="0">
-            <a:spAutoFit/>
-          </a:bodyPr>
-          <a:lstStyle/>
-          <a:p>
-            <a:pPr>
-              <a:spcAft>
-                <a:spcPts val="200"/>
-              </a:spcAft>
-              <a:defRPr sz="1050" b="0">
-                <a:solidFill>
-                  <a:srgbClr val="273D30"/>
-                </a:solidFill>
-                <a:latin typeface="Arial"/>
-              </a:defRPr>
-            </a:pPr>
-            <a:r>
-              <a:t>• Problem: Farmers spend ₹15k-40k/acre on panic chemical spraying, causing export rejections.</a:t>
-            </a:r>
-          </a:p>
-          <a:p>
-            <a:pPr>
-              <a:spcAft>
-                <a:spcPts val="200"/>
-              </a:spcAft>
-              <a:defRPr sz="1050" b="0">
-                <a:solidFill>
-                  <a:srgbClr val="273D30"/>
-                </a:solidFill>
-                <a:latin typeface="Arial"/>
-              </a:defRPr>
-            </a:pPr>
-            <a:r>
-              <a:t>• Solution: Grounded ICAR rules isolate physical observations from unconfirmed hypotheses.</a:t>
-            </a:r>
-          </a:p>
-          <a:p>
-            <a:pPr>
-              <a:spcAft>
-                <a:spcPts val="200"/>
-              </a:spcAft>
-              <a:defRPr sz="1050" b="0">
-                <a:solidFill>
-                  <a:srgbClr val="273D30"/>
-                </a:solidFill>
-                <a:latin typeface="Arial"/>
-              </a:defRPr>
-            </a:pPr>
-            <a:r>
-              <a:t>• ROI &amp; Scale: Cuts pesticide spending by 40-60%; protects EU/US premium export compliance.</a:t>
-            </a:r>
-          </a:p>
-        </p:txBody>
-      </p:sp>
-      <p:sp>
-        <p:nvSpPr>
-          <p:cNvPr id="10" name="TextBox 9"/>
-          <p:cNvSpPr txBox="1"/>
-          <p:nvPr/>
-        </p:nvSpPr>
-        <p:spPr>
-          <a:xfrm>
-            <a:off x="6381750" y="2428875"/>
-            <a:ext cx="5238750" cy="190500"/>
-          </a:xfrm>
-          <a:prstGeom prst="rect">
-            <a:avLst/>
-          </a:prstGeom>
-          <a:noFill/>
-        </p:spPr>
-        <p:txBody>
-          <a:bodyPr wrap="square" lIns="0" tIns="0" rIns="0" bIns="0">
-            <a:spAutoFit/>
-          </a:bodyPr>
-          <a:lstStyle/>
-          <a:p>
-            <a:pPr>
-              <a:spcAft>
-                <a:spcPts val="200"/>
-              </a:spcAft>
-              <a:defRPr sz="1400" b="1">
-                <a:solidFill>
-                  <a:srgbClr val="173F2E"/>
-                </a:solidFill>
-                <a:latin typeface="Arial"/>
-              </a:defRPr>
-            </a:pPr>
-            <a:r>
-              <a:t>4. Fragmented Logs &amp; Lack of Audits</a:t>
-            </a:r>
-          </a:p>
-        </p:txBody>
-      </p:sp>
-      <p:sp>
-        <p:nvSpPr>
-          <p:cNvPr id="11" name="TextBox 10"/>
-          <p:cNvSpPr txBox="1"/>
-          <p:nvPr/>
-        </p:nvSpPr>
-        <p:spPr>
-          <a:xfrm>
-            <a:off x="6381750" y="2647950"/>
-            <a:ext cx="5238750" cy="1047749"/>
-          </a:xfrm>
-          <a:prstGeom prst="rect">
-            <a:avLst/>
-          </a:prstGeom>
-          <a:noFill/>
-        </p:spPr>
-        <p:txBody>
-          <a:bodyPr wrap="square" lIns="0" tIns="0" rIns="0" bIns="0">
-            <a:spAutoFit/>
-          </a:bodyPr>
-          <a:lstStyle/>
-          <a:p>
-            <a:pPr>
-              <a:spcAft>
-                <a:spcPts val="200"/>
-              </a:spcAft>
-              <a:defRPr sz="1050" b="0">
-                <a:solidFill>
-                  <a:srgbClr val="273D30"/>
-                </a:solidFill>
-                <a:latin typeface="Arial"/>
-              </a:defRPr>
-            </a:pPr>
-            <a:r>
-              <a:t>• Problem: Informal WhatsApp/paper notes leave farm managers with zero auditable evidence logs.</a:t>
-            </a:r>
-          </a:p>
-          <a:p>
-            <a:pPr>
-              <a:spcAft>
-                <a:spcPts val="200"/>
-              </a:spcAft>
-              <a:defRPr sz="1050" b="0">
-                <a:solidFill>
-                  <a:srgbClr val="273D30"/>
-                </a:solidFill>
-                <a:latin typeface="Arial"/>
-              </a:defRPr>
-            </a:pPr>
-            <a:r>
-              <a:t>• Solution: Centralized CaseStore with timestamped audit trails &amp; 1-click agronomist reviews.</a:t>
-            </a:r>
-          </a:p>
-          <a:p>
-            <a:pPr>
-              <a:spcAft>
-                <a:spcPts val="200"/>
-              </a:spcAft>
-              <a:defRPr sz="1050" b="0">
-                <a:solidFill>
-                  <a:srgbClr val="273D30"/>
-                </a:solidFill>
-                <a:latin typeface="Arial"/>
-              </a:defRPr>
-            </a:pPr>
-            <a:r>
-              <a:t>• ROI &amp; Scale: Multi-tenant JSON database scales from 2-acre family farms to 1,000+ acre estates.</a:t>
-            </a:r>
-          </a:p>
-        </p:txBody>
-      </p:sp>
-      <p:sp>
-        <p:nvSpPr>
-          <p:cNvPr id="12" name="TextBox 11"/>
-          <p:cNvSpPr txBox="1"/>
-          <p:nvPr/>
-        </p:nvSpPr>
-        <p:spPr>
-          <a:xfrm>
-            <a:off x="571500" y="3857625"/>
+            <a:off x="571500" y="609600"/>
             <a:ext cx="11049000" cy="190500"/>
           </a:xfrm>
           <a:prstGeom prst="rect">
@@ -3640,29 +3161,29 @@
               <a:spcAft>
                 <a:spcPts val="200"/>
               </a:spcAft>
-              <a:defRPr sz="1200" b="1">
-                <a:solidFill>
-                  <a:srgbClr val="173F2E"/>
+              <a:defRPr sz="1200" b="0">
+                <a:solidFill>
+                  <a:srgbClr val="435749"/>
                 </a:solidFill>
                 <a:latin typeface="Arial"/>
               </a:defRPr>
             </a:pPr>
             <a:r>
-              <a:t>STRATEGIC EXECUTION &amp; ROI METRICS</a:t>
-            </a:r>
-          </a:p>
-        </p:txBody>
-      </p:sp>
-      <p:sp>
-        <p:nvSpPr>
-          <p:cNvPr id="13" name="TextBox 12"/>
+              <a:t>Multimodal Vision AI Orchard Inspection &amp; Agronomic Evidence Triage Platform for Alphonso Mangoes</a:t>
+            </a:r>
+          </a:p>
+        </p:txBody>
+      </p:sp>
+      <p:sp>
+        <p:nvSpPr>
+          <p:cNvPr id="4" name="TextBox 3"/>
           <p:cNvSpPr txBox="1"/>
           <p:nvPr/>
         </p:nvSpPr>
         <p:spPr>
           <a:xfrm>
-            <a:off x="571500" y="4076699"/>
-            <a:ext cx="11049000" cy="571500"/>
+            <a:off x="571500" y="952500"/>
+            <a:ext cx="5238750" cy="171450"/>
           </a:xfrm>
           <a:prstGeom prst="rect">
             <a:avLst/>
@@ -3679,23 +3200,46 @@
               <a:spcAft>
                 <a:spcPts val="200"/>
               </a:spcAft>
-              <a:defRPr sz="1000" b="0">
-                <a:solidFill>
-                  <a:srgbClr val="273D30"/>
+              <a:defRPr sz="1300" b="1">
+                <a:solidFill>
+                  <a:srgbClr val="173F2E"/>
                 </a:solidFill>
                 <a:latin typeface="Arial"/>
               </a:defRPr>
             </a:pPr>
             <a:r>
-              <a:t>• COSTING: 92% Total Cost of Ownership reduction using open 4-bit NF4 vision engine vs. commercial vision APIs.</a:t>
-            </a:r>
-          </a:p>
+              <a:t>1. Delayed Disease Triage &amp; Crop Loss</a:t>
+            </a:r>
+          </a:p>
+        </p:txBody>
+      </p:sp>
+      <p:sp>
+        <p:nvSpPr>
+          <p:cNvPr id="5" name="TextBox 4"/>
+          <p:cNvSpPr txBox="1"/>
+          <p:nvPr/>
+        </p:nvSpPr>
+        <p:spPr>
+          <a:xfrm>
+            <a:off x="571500" y="1143000"/>
+            <a:ext cx="5238750" cy="809625"/>
+          </a:xfrm>
+          <a:prstGeom prst="rect">
+            <a:avLst/>
+          </a:prstGeom>
+          <a:noFill/>
+        </p:spPr>
+        <p:txBody>
+          <a:bodyPr wrap="square" lIns="0" tIns="0" rIns="0" bIns="0">
+            <a:spAutoFit/>
+          </a:bodyPr>
+          <a:lstStyle/>
           <a:p>
             <a:pPr>
               <a:spcAft>
                 <a:spcPts val="200"/>
               </a:spcAft>
-              <a:defRPr sz="1000" b="0">
+              <a:defRPr sz="950" b="0">
                 <a:solidFill>
                   <a:srgbClr val="273D30"/>
                 </a:solidFill>
@@ -3703,7 +3247,7 @@
               </a:defRPr>
             </a:pPr>
             <a:r>
-              <a:t>• PERFORMANCE: Sub-6.5s triage response time processing 1,024 vision patches at ~118ms/tok latency on T4 GPU.</a:t>
+              <a:t>• Problem: Alphonso mangoes suffer 35-40% annual crop loss from unmonitored pest outbreaks.</a:t>
             </a:r>
           </a:p>
           <a:p>
@@ -3711,7 +3255,7 @@
               <a:spcAft>
                 <a:spcPts val="200"/>
               </a:spcAft>
-              <a:defRPr sz="1000" b="0">
+              <a:defRPr sz="950" b="0">
                 <a:solidFill>
                   <a:srgbClr val="273D30"/>
                 </a:solidFill>
@@ -3719,20 +3263,366 @@
               </a:defRPr>
             </a:pPr>
             <a:r>
-              <a:t>• SCALABILITY: Multi-tenant JSON storage architecture supporting regional multilingual scale across Konkan.</a:t>
-            </a:r>
-          </a:p>
-        </p:txBody>
-      </p:sp>
-      <p:sp>
-        <p:nvSpPr>
-          <p:cNvPr id="14" name="TextBox 13"/>
+              <a:t>• Solution: Sub-6.5s vision AI triage converts worker photos into actionable agronomic briefs.</a:t>
+            </a:r>
+          </a:p>
+          <a:p>
+            <a:pPr>
+              <a:spcAft>
+                <a:spcPts val="200"/>
+              </a:spcAft>
+              <a:defRPr sz="950" b="0">
+                <a:solidFill>
+                  <a:srgbClr val="273D30"/>
+                </a:solidFill>
+                <a:latin typeface="Arial"/>
+              </a:defRPr>
+            </a:pPr>
+            <a:r>
+              <a:t>• ROI &amp; Scale: Replaces ₹1,500/visit fees; enables 1 agronomist to oversee 500+ orchard blocks.</a:t>
+            </a:r>
+          </a:p>
+        </p:txBody>
+      </p:sp>
+      <p:sp>
+        <p:nvSpPr>
+          <p:cNvPr id="6" name="TextBox 5"/>
           <p:cNvSpPr txBox="1"/>
           <p:nvPr/>
         </p:nvSpPr>
         <p:spPr>
           <a:xfrm>
-            <a:off x="571500" y="4810125"/>
+            <a:off x="6381750" y="952500"/>
+            <a:ext cx="5238750" cy="171450"/>
+          </a:xfrm>
+          <a:prstGeom prst="rect">
+            <a:avLst/>
+          </a:prstGeom>
+          <a:noFill/>
+        </p:spPr>
+        <p:txBody>
+          <a:bodyPr wrap="square" lIns="0" tIns="0" rIns="0" bIns="0">
+            <a:spAutoFit/>
+          </a:bodyPr>
+          <a:lstStyle/>
+          <a:p>
+            <a:pPr>
+              <a:spcAft>
+                <a:spcPts val="200"/>
+              </a:spcAft>
+              <a:defRPr sz="1300" b="1">
+                <a:solidFill>
+                  <a:srgbClr val="173F2E"/>
+                </a:solidFill>
+                <a:latin typeface="Arial"/>
+              </a:defRPr>
+            </a:pPr>
+            <a:r>
+              <a:t>2. Field Worker Language Barrier</a:t>
+            </a:r>
+          </a:p>
+        </p:txBody>
+      </p:sp>
+      <p:sp>
+        <p:nvSpPr>
+          <p:cNvPr id="7" name="TextBox 6"/>
+          <p:cNvSpPr txBox="1"/>
+          <p:nvPr/>
+        </p:nvSpPr>
+        <p:spPr>
+          <a:xfrm>
+            <a:off x="6381750" y="1143000"/>
+            <a:ext cx="5238750" cy="809625"/>
+          </a:xfrm>
+          <a:prstGeom prst="rect">
+            <a:avLst/>
+          </a:prstGeom>
+          <a:noFill/>
+        </p:spPr>
+        <p:txBody>
+          <a:bodyPr wrap="square" lIns="0" tIns="0" rIns="0" bIns="0">
+            <a:spAutoFit/>
+          </a:bodyPr>
+          <a:lstStyle/>
+          <a:p>
+            <a:pPr>
+              <a:spcAft>
+                <a:spcPts val="200"/>
+              </a:spcAft>
+              <a:defRPr sz="950" b="0">
+                <a:solidFill>
+                  <a:srgbClr val="273D30"/>
+                </a:solidFill>
+                <a:latin typeface="Arial"/>
+              </a:defRPr>
+            </a:pPr>
+            <a:r>
+              <a:t>• Problem: Over 85% of Konkan orchard workers are native Marathi or Hindi speakers.</a:t>
+            </a:r>
+          </a:p>
+          <a:p>
+            <a:pPr>
+              <a:spcAft>
+                <a:spcPts val="200"/>
+              </a:spcAft>
+              <a:defRPr sz="950" b="0">
+                <a:solidFill>
+                  <a:srgbClr val="273D30"/>
+                </a:solidFill>
+                <a:latin typeface="Arial"/>
+              </a:defRPr>
+            </a:pPr>
+            <a:r>
+              <a:t>• Solution: Multilingual UI (EN, MR, HI) dynamically aligns local terms (Karpa) to AI tensors.</a:t>
+            </a:r>
+          </a:p>
+          <a:p>
+            <a:pPr>
+              <a:spcAft>
+                <a:spcPts val="200"/>
+              </a:spcAft>
+              <a:defRPr sz="950" b="0">
+                <a:solidFill>
+                  <a:srgbClr val="273D30"/>
+                </a:solidFill>
+                <a:latin typeface="Arial"/>
+              </a:defRPr>
+            </a:pPr>
+            <a:r>
+              <a:t>• ROI &amp; Scale: Zero worker training costs; seamless adoption across regional labor pools.</a:t>
+            </a:r>
+          </a:p>
+        </p:txBody>
+      </p:sp>
+      <p:sp>
+        <p:nvSpPr>
+          <p:cNvPr id="8" name="TextBox 7"/>
+          <p:cNvSpPr txBox="1"/>
+          <p:nvPr/>
+        </p:nvSpPr>
+        <p:spPr>
+          <a:xfrm>
+            <a:off x="571500" y="2190750"/>
+            <a:ext cx="5238750" cy="171450"/>
+          </a:xfrm>
+          <a:prstGeom prst="rect">
+            <a:avLst/>
+          </a:prstGeom>
+          <a:noFill/>
+        </p:spPr>
+        <p:txBody>
+          <a:bodyPr wrap="square" lIns="0" tIns="0" rIns="0" bIns="0">
+            <a:spAutoFit/>
+          </a:bodyPr>
+          <a:lstStyle/>
+          <a:p>
+            <a:pPr>
+              <a:spcAft>
+                <a:spcPts val="200"/>
+              </a:spcAft>
+              <a:defRPr sz="1300" b="1">
+                <a:solidFill>
+                  <a:srgbClr val="173F2E"/>
+                </a:solidFill>
+                <a:latin typeface="Arial"/>
+              </a:defRPr>
+            </a:pPr>
+            <a:r>
+              <a:t>3. Over-Spraying &amp; Export Rejections</a:t>
+            </a:r>
+          </a:p>
+        </p:txBody>
+      </p:sp>
+      <p:sp>
+        <p:nvSpPr>
+          <p:cNvPr id="9" name="TextBox 8"/>
+          <p:cNvSpPr txBox="1"/>
+          <p:nvPr/>
+        </p:nvSpPr>
+        <p:spPr>
+          <a:xfrm>
+            <a:off x="571500" y="2381250"/>
+            <a:ext cx="5238750" cy="809625"/>
+          </a:xfrm>
+          <a:prstGeom prst="rect">
+            <a:avLst/>
+          </a:prstGeom>
+          <a:noFill/>
+        </p:spPr>
+        <p:txBody>
+          <a:bodyPr wrap="square" lIns="0" tIns="0" rIns="0" bIns="0">
+            <a:spAutoFit/>
+          </a:bodyPr>
+          <a:lstStyle/>
+          <a:p>
+            <a:pPr>
+              <a:spcAft>
+                <a:spcPts val="200"/>
+              </a:spcAft>
+              <a:defRPr sz="950" b="0">
+                <a:solidFill>
+                  <a:srgbClr val="273D30"/>
+                </a:solidFill>
+                <a:latin typeface="Arial"/>
+              </a:defRPr>
+            </a:pPr>
+            <a:r>
+              <a:t>• Problem: Farmers spend ₹15k-40k/acre on panic chemical spraying, causing export rejections.</a:t>
+            </a:r>
+          </a:p>
+          <a:p>
+            <a:pPr>
+              <a:spcAft>
+                <a:spcPts val="200"/>
+              </a:spcAft>
+              <a:defRPr sz="950" b="0">
+                <a:solidFill>
+                  <a:srgbClr val="273D30"/>
+                </a:solidFill>
+                <a:latin typeface="Arial"/>
+              </a:defRPr>
+            </a:pPr>
+            <a:r>
+              <a:t>• Solution: Grounded ICAR rules isolate physical observations from unconfirmed hypotheses.</a:t>
+            </a:r>
+          </a:p>
+          <a:p>
+            <a:pPr>
+              <a:spcAft>
+                <a:spcPts val="200"/>
+              </a:spcAft>
+              <a:defRPr sz="950" b="0">
+                <a:solidFill>
+                  <a:srgbClr val="273D30"/>
+                </a:solidFill>
+                <a:latin typeface="Arial"/>
+              </a:defRPr>
+            </a:pPr>
+            <a:r>
+              <a:t>• ROI &amp; Scale: Cuts pesticide spending by 40-60%; protects EU/US premium export compliance.</a:t>
+            </a:r>
+          </a:p>
+        </p:txBody>
+      </p:sp>
+      <p:sp>
+        <p:nvSpPr>
+          <p:cNvPr id="10" name="TextBox 9"/>
+          <p:cNvSpPr txBox="1"/>
+          <p:nvPr/>
+        </p:nvSpPr>
+        <p:spPr>
+          <a:xfrm>
+            <a:off x="6381750" y="2190750"/>
+            <a:ext cx="5238750" cy="171450"/>
+          </a:xfrm>
+          <a:prstGeom prst="rect">
+            <a:avLst/>
+          </a:prstGeom>
+          <a:noFill/>
+        </p:spPr>
+        <p:txBody>
+          <a:bodyPr wrap="square" lIns="0" tIns="0" rIns="0" bIns="0">
+            <a:spAutoFit/>
+          </a:bodyPr>
+          <a:lstStyle/>
+          <a:p>
+            <a:pPr>
+              <a:spcAft>
+                <a:spcPts val="200"/>
+              </a:spcAft>
+              <a:defRPr sz="1300" b="1">
+                <a:solidFill>
+                  <a:srgbClr val="173F2E"/>
+                </a:solidFill>
+                <a:latin typeface="Arial"/>
+              </a:defRPr>
+            </a:pPr>
+            <a:r>
+              <a:t>4. Fragmented Logs &amp; Lack of Audits</a:t>
+            </a:r>
+          </a:p>
+        </p:txBody>
+      </p:sp>
+      <p:sp>
+        <p:nvSpPr>
+          <p:cNvPr id="11" name="TextBox 10"/>
+          <p:cNvSpPr txBox="1"/>
+          <p:nvPr/>
+        </p:nvSpPr>
+        <p:spPr>
+          <a:xfrm>
+            <a:off x="6381750" y="2381250"/>
+            <a:ext cx="5238750" cy="809625"/>
+          </a:xfrm>
+          <a:prstGeom prst="rect">
+            <a:avLst/>
+          </a:prstGeom>
+          <a:noFill/>
+        </p:spPr>
+        <p:txBody>
+          <a:bodyPr wrap="square" lIns="0" tIns="0" rIns="0" bIns="0">
+            <a:spAutoFit/>
+          </a:bodyPr>
+          <a:lstStyle/>
+          <a:p>
+            <a:pPr>
+              <a:spcAft>
+                <a:spcPts val="200"/>
+              </a:spcAft>
+              <a:defRPr sz="950" b="0">
+                <a:solidFill>
+                  <a:srgbClr val="273D30"/>
+                </a:solidFill>
+                <a:latin typeface="Arial"/>
+              </a:defRPr>
+            </a:pPr>
+            <a:r>
+              <a:t>• Problem: Informal WhatsApp/paper notes leave farm managers with zero auditable evidence logs.</a:t>
+            </a:r>
+          </a:p>
+          <a:p>
+            <a:pPr>
+              <a:spcAft>
+                <a:spcPts val="200"/>
+              </a:spcAft>
+              <a:defRPr sz="950" b="0">
+                <a:solidFill>
+                  <a:srgbClr val="273D30"/>
+                </a:solidFill>
+                <a:latin typeface="Arial"/>
+              </a:defRPr>
+            </a:pPr>
+            <a:r>
+              <a:t>• Solution: Centralized CaseStore with timestamped audit trails &amp; 1-click agronomist reviews.</a:t>
+            </a:r>
+          </a:p>
+          <a:p>
+            <a:pPr>
+              <a:spcAft>
+                <a:spcPts val="200"/>
+              </a:spcAft>
+              <a:defRPr sz="950" b="0">
+                <a:solidFill>
+                  <a:srgbClr val="273D30"/>
+                </a:solidFill>
+                <a:latin typeface="Arial"/>
+              </a:defRPr>
+            </a:pPr>
+            <a:r>
+              <a:t>• ROI &amp; Scale: Multi-tenant JSON database scales from 2-acre family farms to 1,000+ acre estates.</a:t>
+            </a:r>
+          </a:p>
+        </p:txBody>
+      </p:sp>
+      <p:sp>
+        <p:nvSpPr>
+          <p:cNvPr id="12" name="TextBox 11"/>
+          <p:cNvSpPr txBox="1"/>
+          <p:nvPr/>
+        </p:nvSpPr>
+        <p:spPr>
+          <a:xfrm>
+            <a:off x="571500" y="3429000"/>
             <a:ext cx="11049000" cy="171450"/>
           </a:xfrm>
           <a:prstGeom prst="rect">
@@ -3750,7 +3640,117 @@
               <a:spcAft>
                 <a:spcPts val="200"/>
               </a:spcAft>
-              <a:defRPr sz="1000" b="1">
+              <a:defRPr sz="1100" b="1">
+                <a:solidFill>
+                  <a:srgbClr val="173F2E"/>
+                </a:solidFill>
+                <a:latin typeface="Arial"/>
+              </a:defRPr>
+            </a:pPr>
+            <a:r>
+              <a:t>STRATEGIC EXECUTION &amp; ROI METRICS</a:t>
+            </a:r>
+          </a:p>
+        </p:txBody>
+      </p:sp>
+      <p:sp>
+        <p:nvSpPr>
+          <p:cNvPr id="13" name="TextBox 12"/>
+          <p:cNvSpPr txBox="1"/>
+          <p:nvPr/>
+        </p:nvSpPr>
+        <p:spPr>
+          <a:xfrm>
+            <a:off x="571500" y="3619500"/>
+            <a:ext cx="11049000" cy="714375"/>
+          </a:xfrm>
+          <a:prstGeom prst="rect">
+            <a:avLst/>
+          </a:prstGeom>
+          <a:noFill/>
+        </p:spPr>
+        <p:txBody>
+          <a:bodyPr wrap="square" lIns="0" tIns="0" rIns="0" bIns="0">
+            <a:spAutoFit/>
+          </a:bodyPr>
+          <a:lstStyle/>
+          <a:p>
+            <a:pPr>
+              <a:spcAft>
+                <a:spcPts val="200"/>
+              </a:spcAft>
+              <a:defRPr sz="950" b="0">
+                <a:solidFill>
+                  <a:srgbClr val="273D30"/>
+                </a:solidFill>
+                <a:latin typeface="Arial"/>
+              </a:defRPr>
+            </a:pPr>
+            <a:r>
+              <a:t>• COSTING: 92% Total Cost of Ownership reduction using open 4-bit NF4 vision engine vs. commercial vision APIs.</a:t>
+            </a:r>
+          </a:p>
+          <a:p>
+            <a:pPr>
+              <a:spcAft>
+                <a:spcPts val="200"/>
+              </a:spcAft>
+              <a:defRPr sz="950" b="0">
+                <a:solidFill>
+                  <a:srgbClr val="273D30"/>
+                </a:solidFill>
+                <a:latin typeface="Arial"/>
+              </a:defRPr>
+            </a:pPr>
+            <a:r>
+              <a:t>• PERFORMANCE: Sub-6.5s triage response time processing 1,024 vision patches at ~118ms/tok latency on T4 GPU.</a:t>
+            </a:r>
+          </a:p>
+          <a:p>
+            <a:pPr>
+              <a:spcAft>
+                <a:spcPts val="200"/>
+              </a:spcAft>
+              <a:defRPr sz="950" b="0">
+                <a:solidFill>
+                  <a:srgbClr val="273D30"/>
+                </a:solidFill>
+                <a:latin typeface="Arial"/>
+              </a:defRPr>
+            </a:pPr>
+            <a:r>
+              <a:t>• SCALABILITY: Multi-tenant JSON storage architecture supporting regional multilingual scale across Konkan.</a:t>
+            </a:r>
+          </a:p>
+        </p:txBody>
+      </p:sp>
+      <p:sp>
+        <p:nvSpPr>
+          <p:cNvPr id="14" name="TextBox 13"/>
+          <p:cNvSpPr txBox="1"/>
+          <p:nvPr/>
+        </p:nvSpPr>
+        <p:spPr>
+          <a:xfrm>
+            <a:off x="571500" y="4619625"/>
+            <a:ext cx="11049000" cy="152400"/>
+          </a:xfrm>
+          <a:prstGeom prst="rect">
+            <a:avLst/>
+          </a:prstGeom>
+          <a:noFill/>
+        </p:spPr>
+        <p:txBody>
+          <a:bodyPr wrap="square" lIns="0" tIns="0" rIns="0" bIns="0">
+            <a:spAutoFit/>
+          </a:bodyPr>
+          <a:lstStyle/>
+          <a:p>
+            <a:pPr>
+              <a:spcAft>
+                <a:spcPts val="200"/>
+              </a:spcAft>
+              <a:defRPr sz="950" b="1">
                 <a:solidFill>
                   <a:srgbClr val="6D6345"/>
                 </a:solidFill>
@@ -3771,7 +3771,7 @@
         </p:nvSpPr>
         <p:spPr>
           <a:xfrm>
-            <a:off x="571500" y="5000625"/>
+            <a:off x="571500" y="4791075"/>
             <a:ext cx="11049000" cy="381000"/>
           </a:xfrm>
           <a:prstGeom prst="rect">
@@ -3789,7 +3789,7 @@
               <a:spcAft>
                 <a:spcPts val="200"/>
               </a:spcAft>
-              <a:defRPr sz="900" b="0">
+              <a:defRPr sz="850" b="0">
                 <a:solidFill>
                   <a:srgbClr val="6D6345"/>
                 </a:solidFill>
@@ -3805,7 +3805,7 @@
               <a:spcAft>
                 <a:spcPts val="200"/>
               </a:spcAft>
-              <a:defRPr sz="900" b="0">
+              <a:defRPr sz="850" b="0">
                 <a:solidFill>
                   <a:srgbClr val="6D6345"/>
                 </a:solidFill>

</xml_diff>

<commit_message>
fix(pitch): clean title and footer wording by removing draft and track labels
</commit_message>
<xml_diff>
--- a/output/presentation/hapus-scout-day1.pptx
+++ b/output/presentation/hapus-scout-day1.pptx
@@ -3122,7 +3122,7 @@
               <a:spcAft>
                 <a:spcPts val="200"/>
               </a:spcAft>
-              <a:defRPr sz="2400" b="1">
+              <a:defRPr sz="2600" b="1">
                 <a:solidFill>
                   <a:srgbClr val="173F2E"/>
                 </a:solidFill>
@@ -3130,7 +3130,7 @@
               </a:defRPr>
             </a:pPr>
             <a:r>
-              <a:t>Hapus Scout™ Enterprise — 1-Page Executive Pitch</a:t>
+              <a:t>Hapus Scout™ Enterprise</a:t>
             </a:r>
           </a:p>
         </p:txBody>
@@ -3813,7 +3813,7 @@
               </a:defRPr>
             </a:pPr>
             <a:r>
-              <a:t>• Live Repository: https://github.com/HarshadHindlekar/Hapus-Scout.git  |  Vertical AI Track — Day-1 Builders Pitch Fest Edition</a:t>
+              <a:t>• Live Repository: https://github.com/HarshadHindlekar/Hapus-Scout.git</a:t>
             </a:r>
           </a:p>
         </p:txBody>

</xml_diff>

<commit_message>
fix(pitch): rewrite presentation slides into simple, easy-to-understand plain English
</commit_message>
<xml_diff>
--- a/output/presentation/hapus-scout-day1.pptx
+++ b/output/presentation/hapus-scout-day1.pptx
@@ -3122,7 +3122,7 @@
               <a:spcAft>
                 <a:spcPts val="200"/>
               </a:spcAft>
-              <a:defRPr sz="2600" b="1">
+              <a:defRPr sz="2400" b="1">
                 <a:solidFill>
                   <a:srgbClr val="173F2E"/>
                 </a:solidFill>
@@ -3130,7 +3130,7 @@
               </a:defRPr>
             </a:pPr>
             <a:r>
-              <a:t>Hapus Scout™ Enterprise</a:t>
+              <a:t>Hapus Scout™ Enterprise — Smart AI Inspection for Mango Farms</a:t>
             </a:r>
           </a:p>
         </p:txBody>
@@ -3169,7 +3169,7 @@
               </a:defRPr>
             </a:pPr>
             <a:r>
-              <a:t>Multimodal Vision AI Orchard Inspection &amp; Agronomic Evidence Triage Platform for Alphonso Mangoes</a:t>
+              <a:t>Helping Alphonso mango farm workers spot crop diseases early and share instant photo reports with farm managers.</a:t>
             </a:r>
           </a:p>
         </p:txBody>
@@ -3208,7 +3208,7 @@
               </a:defRPr>
             </a:pPr>
             <a:r>
-              <a:t>1. Delayed Disease Triage &amp; Crop Loss</a:t>
+              <a:t>1. Slow Disease Detection Causes 40% Crop Loss</a:t>
             </a:r>
           </a:p>
         </p:txBody>
@@ -3247,7 +3247,7 @@
               </a:defRPr>
             </a:pPr>
             <a:r>
-              <a:t>• Problem: Alphonso mangoes suffer 35-40% annual crop loss from unmonitored pest outbreaks.</a:t>
+              <a:t>• Problem: Alphonso farmers lose nearly 40% of their mangoes each year because diseases spread unseen.</a:t>
             </a:r>
           </a:p>
           <a:p>
@@ -3263,7 +3263,7 @@
               </a:defRPr>
             </a:pPr>
             <a:r>
-              <a:t>• Solution: Sub-6.5s vision AI triage converts worker photos into actionable agronomic briefs.</a:t>
+              <a:t>• Solution: Workers upload a photo and get a clear AI checkup report in less than 7 seconds.</a:t>
             </a:r>
           </a:p>
           <a:p>
@@ -3279,7 +3279,7 @@
               </a:defRPr>
             </a:pPr>
             <a:r>
-              <a:t>• ROI &amp; Scale: Replaces ₹1,500/visit fees; enables 1 agronomist to oversee 500+ orchard blocks.</a:t>
+              <a:t>• Impact: Saves ₹1,500 per expert visit; allows 1 manager to easily look after 500+ orchard blocks.</a:t>
             </a:r>
           </a:p>
         </p:txBody>
@@ -3318,7 +3318,7 @@
               </a:defRPr>
             </a:pPr>
             <a:r>
-              <a:t>2. Field Worker Language Barrier</a:t>
+              <a:t>2. Language Barrier for Farm Workers</a:t>
             </a:r>
           </a:p>
         </p:txBody>
@@ -3357,7 +3357,7 @@
               </a:defRPr>
             </a:pPr>
             <a:r>
-              <a:t>• Problem: Over 85% of Konkan orchard workers are native Marathi or Hindi speakers.</a:t>
+              <a:t>• Problem: Over 85% of workers speak only Marathi or Hindi and cannot use complicated English apps.</a:t>
             </a:r>
           </a:p>
           <a:p>
@@ -3373,7 +3373,7 @@
               </a:defRPr>
             </a:pPr>
             <a:r>
-              <a:t>• Solution: Multilingual UI (EN, MR, HI) dynamically aligns local terms (Karpa) to AI tensors.</a:t>
+              <a:t>• Solution: Simple 1-click switch between English, Marathi (मराठी), and Hindi (हिंदी).</a:t>
             </a:r>
           </a:p>
           <a:p>
@@ -3389,7 +3389,7 @@
               </a:defRPr>
             </a:pPr>
             <a:r>
-              <a:t>• ROI &amp; Scale: Zero worker training costs; seamless adoption across regional labor pools.</a:t>
+              <a:t>• Impact: Workers can report symptoms in their own native language with zero training needed.</a:t>
             </a:r>
           </a:p>
         </p:txBody>
@@ -3428,7 +3428,7 @@
               </a:defRPr>
             </a:pPr>
             <a:r>
-              <a:t>3. Over-Spraying &amp; Export Rejections</a:t>
+              <a:t>3. Wasting Money on Wrong Pesticide Sprays</a:t>
             </a:r>
           </a:p>
         </p:txBody>
@@ -3467,7 +3467,7 @@
               </a:defRPr>
             </a:pPr>
             <a:r>
-              <a:t>• Problem: Farmers spend ₹15k-40k/acre on panic chemical spraying, causing export rejections.</a:t>
+              <a:t>• Problem: Scared farmers spend ₹15,000 to ₹40,000 per acre buying wrong sprays, harming crop exports.</a:t>
             </a:r>
           </a:p>
           <a:p>
@@ -3483,7 +3483,7 @@
               </a:defRPr>
             </a:pPr>
             <a:r>
-              <a:t>• Solution: Grounded ICAR rules isolate physical observations from unconfirmed hypotheses.</a:t>
+              <a:t>• Solution: AI follows official government farming rules (ICAR) and separates facts from guesses.</a:t>
             </a:r>
           </a:p>
           <a:p>
@@ -3499,7 +3499,7 @@
               </a:defRPr>
             </a:pPr>
             <a:r>
-              <a:t>• ROI &amp; Scale: Cuts pesticide spending by 40-60%; protects EU/US premium export compliance.</a:t>
+              <a:t>• Impact: Cuts pesticide costs by 40% to 60% and keeps mangoes safe for international export.</a:t>
             </a:r>
           </a:p>
         </p:txBody>
@@ -3538,7 +3538,7 @@
               </a:defRPr>
             </a:pPr>
             <a:r>
-              <a:t>4. Fragmented Logs &amp; Lack of Audits</a:t>
+              <a:t>4. Lost Paper Records &amp; Messy Chat Messages</a:t>
             </a:r>
           </a:p>
         </p:txBody>
@@ -3577,7 +3577,7 @@
               </a:defRPr>
             </a:pPr>
             <a:r>
-              <a:t>• Problem: Informal WhatsApp/paper notes leave farm managers with zero auditable evidence logs.</a:t>
+              <a:t>• Problem: Farm notes get lost on WhatsApp or paper, giving managers no real inspection history.</a:t>
             </a:r>
           </a:p>
           <a:p>
@@ -3593,7 +3593,7 @@
               </a:defRPr>
             </a:pPr>
             <a:r>
-              <a:t>• Solution: Centralized CaseStore with timestamped audit trails &amp; 1-click agronomist reviews.</a:t>
+              <a:t>• Solution: Automatic digital library stores every photo, symptom report, and manager review.</a:t>
             </a:r>
           </a:p>
           <a:p>
@@ -3609,7 +3609,7 @@
               </a:defRPr>
             </a:pPr>
             <a:r>
-              <a:t>• ROI &amp; Scale: Multi-tenant JSON database scales from 2-acre family farms to 1,000+ acre estates.</a:t>
+              <a:t>• Impact: Works for small 2-acre family farms as well as large 1,000-acre commercial estates.</a:t>
             </a:r>
           </a:p>
         </p:txBody>
@@ -3648,7 +3648,7 @@
               </a:defRPr>
             </a:pPr>
             <a:r>
-              <a:t>STRATEGIC EXECUTION &amp; ROI METRICS</a:t>
+              <a:t>KEY ADVANTAGES: COST, SPEED &amp; SCALABILITY</a:t>
             </a:r>
           </a:p>
         </p:txBody>
@@ -3687,7 +3687,7 @@
               </a:defRPr>
             </a:pPr>
             <a:r>
-              <a:t>• COSTING: 92% Total Cost of Ownership reduction using open 4-bit NF4 vision engine vs. commercial vision APIs.</a:t>
+              <a:t>• LOW COST: 90%+ cheaper to run by using smart lightweight local AI models on low-cost devices.</a:t>
             </a:r>
           </a:p>
           <a:p>
@@ -3703,7 +3703,7 @@
               </a:defRPr>
             </a:pPr>
             <a:r>
-              <a:t>• PERFORMANCE: Sub-6.5s triage response time processing 1,024 vision patches at ~118ms/tok latency on T4 GPU.</a:t>
+              <a:t>• FAST SPEED: Under 7 seconds per photo checkup so workers get instant answers right on the field.</a:t>
             </a:r>
           </a:p>
           <a:p>
@@ -3719,7 +3719,7 @@
               </a:defRPr>
             </a:pPr>
             <a:r>
-              <a:t>• SCALABILITY: Multi-tenant JSON storage architecture supporting regional multilingual scale across Konkan.</a:t>
+              <a:t>• EASY TO SCALE: Native Marathi/Hindi support allows rapid deployment across all Konkan mango farms.</a:t>
             </a:r>
           </a:p>
         </p:txBody>
@@ -3758,7 +3758,7 @@
               </a:defRPr>
             </a:pPr>
             <a:r>
-              <a:t>AGRONOMIC GUARDRAIL &amp; REPOSITORY INFORMATION</a:t>
+              <a:t>SAFETY NOTICE &amp; PROJECT LINK</a:t>
             </a:r>
           </a:p>
         </p:txBody>
@@ -3797,7 +3797,7 @@
               </a:defRPr>
             </a:pPr>
             <a:r>
-              <a:t>• Agronomic Guardrail Notice: AI analysis supports triage evidence isolation. Certified agronomist verification mandatory before chemical application.</a:t>
+              <a:t>• Farm Safety Notice: AI assists initial checking only. Certified farming experts must verify before chemical spraying.</a:t>
             </a:r>
           </a:p>
           <a:p>
@@ -3813,7 +3813,7 @@
               </a:defRPr>
             </a:pPr>
             <a:r>
-              <a:t>• Live Repository: https://github.com/HarshadHindlekar/Hapus-Scout.git</a:t>
+              <a:t>• Open Code Repository: https://github.com/HarshadHindlekar/Hapus-Scout.git</a:t>
             </a:r>
           </a:p>
         </p:txBody>

</xml_diff>